<commit_message>
ajusta el umbral a cribado y publica el notebook con sus outputs
Umbral por modelo elegido en VALIDACION fijando una sensibilidad objetivo del
90% y quedandose con la mejor especificidad que la cumpla, en lugar de heredar
0.5. Maximizar el recall sin restriccion daria umbral 0 y todo positivo, que es
sensibilidad 1 con especificidad 0.

El informe compara ahora los tres puntos de operacion del MISMO modelo (0.5,
Youden y cribado): el umbral mueve la sensibilidad mas que la arquitectura, y
Youden equilibra los dos errores cuando aqui tienen coste muy distinto.

El notebook se ejecuta en Kaggle y Kaggle no expone por API el .ipynb ejecutado,
asi que cada celda imprime un centinela y reconstruir_notebook_ejecutado.py parte
el log por ese marcador para adjuntarle a cada celda su salida real y las figuras
que guardo. Antes se commiteaba sin ningun output.
</commit_message>
<xml_diff>
--- a/presentacion/proyecto2-resultados-cervical.pptx
+++ b/presentacion/proyecto2-resultados-cervical.pptx
@@ -3847,7 +3847,7 @@
                 </a:solidFill>
                 <a:latin typeface="Segoe UI"/>
               </a:rPr>
-              <a:t>0.765</a:t>
+              <a:t>0.774</a:t>
             </a:r>
           </a:p>
         </p:txBody>
@@ -4009,7 +4009,7 @@
                 </a:solidFill>
                 <a:latin typeface="Segoe UI"/>
               </a:rPr>
-              <a:t>+0.047</a:t>
+              <a:t>+0.101</a:t>
             </a:r>
           </a:p>
         </p:txBody>
@@ -6667,7 +6667,7 @@
                 <a:latin typeface="Segoe UI"/>
               </a:rPr>
               <a:t>CNN propia (desde cero)
-308 s de entrenamiento</a:t>
+284 s de entrenamiento</a:t>
             </a:r>
           </a:p>
         </p:txBody>
@@ -6829,7 +6829,7 @@
                 <a:latin typeface="Segoe UI"/>
               </a:rPr>
               <a:t>MobileNetV2 (ImageNet)
-579 s de entrenamiento</a:t>
+467 s de entrenamiento</a:t>
             </a:r>
           </a:p>
         </p:txBody>
@@ -6991,7 +6991,7 @@
                 <a:latin typeface="Segoe UI"/>
               </a:rPr>
               <a:t>EfficientNetB0 (ImageNet)
-515 s de entrenamiento</a:t>
+562 s de entrenamiento</a:t>
             </a:r>
           </a:p>
         </p:txBody>
@@ -7378,7 +7378,7 @@
                 </a:solidFill>
                 <a:latin typeface="Segoe UI"/>
               </a:rPr>
-              <a:t>ROC-AUC 0.7647</a:t>
+              <a:t>ROC-AUC 0.7740</a:t>
             </a:r>
           </a:p>
           <a:p>
@@ -7435,7 +7435,7 @@
                 </a:solidFill>
                 <a:latin typeface="Segoe UI"/>
               </a:rPr>
-              <a:t>0.718 → 0.730 → 0.765</a:t>
+              <a:t>0.673 → 0.725 → 0.774</a:t>
             </a:r>
           </a:p>
           <a:p>
@@ -7492,7 +7492,7 @@
                 </a:solidFill>
                 <a:latin typeface="Segoe UI"/>
               </a:rPr>
-              <a:t>La transferencia aporta 0.047 de AUC</a:t>
+              <a:t>La transferencia aporta 0.101 de AUC</a:t>
             </a:r>
           </a:p>
           <a:p>
@@ -7992,7 +7992,7 @@
                 </a:solidFill>
                 <a:latin typeface="Segoe UI"/>
               </a:rPr>
-              <a:t>CNN propia (desde cero) responde en 1.6 ms por imagen.</a:t>
+              <a:t>CNN propia (desde cero) responde en 0.9 ms por imagen.</a:t>
             </a:r>
           </a:p>
           <a:p>

</xml_diff>

<commit_message>
alinea presentacion y figura de matrices con el umbral de cribado
- Diapositivas 5 y 7 decian que el umbral se elige por Youden; el umbral
  publicado es el de cribado (sensibilidad >= 90 % en validacion).
- 06_matrices_confusion.png se titulaba "umbral 0.5" pero sus valores son
  los del umbral de cribado. Se regenera desde Aplicacion/metrics/*.json con
  el titulo correcto y se corrige el titulo en el notebook 06.
- Regenera el .pptx y el PDF del informe con la figura nueva.
</commit_message>
<xml_diff>
--- a/presentacion/proyecto2-resultados-cervical.pptx
+++ b/presentacion/proyecto2-resultados-cervical.pptx
@@ -7109,7 +7109,7 @@
                 </a:solidFill>
                 <a:latin typeface="Segoe UI"/>
               </a:rPr>
-              <a:t>Umbral elegido en validación por índice de Youden</a:t>
+              <a:t>Umbral de cribado elegido en validación</a:t>
             </a:r>
           </a:p>
           <a:p>
@@ -7128,7 +7128,7 @@
                 </a:solidFill>
                 <a:latin typeface="Segoe UI"/>
               </a:rPr>
-              <a:t>   no se hereda 0.5: un modelo puede ordenar bien y aun así estar descalibrado.</a:t>
+              <a:t>   sensibilidad ≥ 90% con la mejor especificidad posible, en lugar de 0.5 o Youden.</a:t>
             </a:r>
           </a:p>
         </p:txBody>
@@ -7761,7 +7761,7 @@
                 </a:solidFill>
                 <a:latin typeface="Segoe UI"/>
               </a:rPr>
-              <a:t>Un falso negativo es una fractura no diagnosticada, con riesgo de deterioro neurológico; un falso positivo solo genera una revisión. Por eso el umbral se elige en validación maximizando sensibilidad + especificidad, y queda configurable por modelo en models.yaml: es una decisión explícita, no el 0.5 por defecto.</a:t>
+              <a:t>Un falso negativo es una fractura no diagnosticada, con riesgo de deterioro neurológico; un falso positivo solo genera una revisión. Por eso el umbral se fija en validación para alcanzar al menos 90% de sensibilidad con la mejor especificidad posible, y queda configurable por modelo en models.yaml: es una decisión explícita, no el 0.5 por defecto.</a:t>
             </a:r>
           </a:p>
         </p:txBody>

</xml_diff>